<commit_message>
changes in frontend and backend
</commit_message>
<xml_diff>
--- a/backend/pitchbook.pptx
+++ b/backend/pitchbook.pptx
@@ -3259,17 +3259,17 @@
           </a:p>
           <a:p>
             <a:r>
-              <a:t>INFY | $12.24 | 15.7x | 10.6x</a:t>
-            </a:r>
-          </a:p>
-          <a:p>
-            <a:r>
-              <a:t>ACN | $180.12 | 14.8x | 8.7x</a:t>
-            </a:r>
-          </a:p>
-          <a:p>
-            <a:r>
-              <a:t>CTSH | $51.86 | 11.2x | 6.2x</a:t>
+              <a:t>INFY | $12.64 | 15.8x | 10.9x</a:t>
+            </a:r>
+          </a:p>
+          <a:p>
+            <a:r>
+              <a:t>ACN | $174.57 | 14.3x | 8.5x</a:t>
+            </a:r>
+          </a:p>
+          <a:p>
+            <a:r>
+              <a:t>CTSH | $51.33 | 11.1x | 6.1x</a:t>
             </a:r>
           </a:p>
           <a:p/>

</xml_diff>